<commit_message>
Flatten carousel to a LinkedIn-friendly raster PDF
</commit_message>
<xml_diff>
--- a/deck/ai-use-case-portfolio-carousel.pptx
+++ b/deck/ai-use-case-portfolio-carousel.pptx
@@ -2500,13 +2500,6 @@
             </a:solidFill>
             <a:prstDash val="solid"/>
           </a:ln>
-          <a:effectLst>
-            <a:outerShdw sx="100000" sy="100000" kx="0" ky="0" algn="bl" rotWithShape="0" blurRad="76200" dist="25400" dir="5400000">
-              <a:srgbClr val="9AA7BD">
-                <a:alpha val="20000"/>
-              </a:srgbClr>
-            </a:outerShdw>
-          </a:effectLst>
         </p:spPr>
       </p:sp>
       <p:sp>
@@ -2654,13 +2647,6 @@
             </a:solidFill>
             <a:prstDash val="solid"/>
           </a:ln>
-          <a:effectLst>
-            <a:outerShdw sx="100000" sy="100000" kx="0" ky="0" algn="bl" rotWithShape="0" blurRad="76200" dist="25400" dir="5400000">
-              <a:srgbClr val="9AA7BD">
-                <a:alpha val="20000"/>
-              </a:srgbClr>
-            </a:outerShdw>
-          </a:effectLst>
         </p:spPr>
       </p:sp>
       <p:sp>
@@ -2808,13 +2794,6 @@
             </a:solidFill>
             <a:prstDash val="solid"/>
           </a:ln>
-          <a:effectLst>
-            <a:outerShdw sx="100000" sy="100000" kx="0" ky="0" algn="bl" rotWithShape="0" blurRad="76200" dist="25400" dir="5400000">
-              <a:srgbClr val="9AA7BD">
-                <a:alpha val="20000"/>
-              </a:srgbClr>
-            </a:outerShdw>
-          </a:effectLst>
         </p:spPr>
       </p:sp>
       <p:sp>
@@ -2962,13 +2941,6 @@
             </a:solidFill>
             <a:prstDash val="solid"/>
           </a:ln>
-          <a:effectLst>
-            <a:outerShdw sx="100000" sy="100000" kx="0" ky="0" algn="bl" rotWithShape="0" blurRad="76200" dist="25400" dir="5400000">
-              <a:srgbClr val="9AA7BD">
-                <a:alpha val="20000"/>
-              </a:srgbClr>
-            </a:outerShdw>
-          </a:effectLst>
         </p:spPr>
       </p:sp>
       <p:sp>
@@ -3307,13 +3279,6 @@
             </a:solidFill>
             <a:prstDash val="solid"/>
           </a:ln>
-          <a:effectLst>
-            <a:outerShdw sx="100000" sy="100000" kx="0" ky="0" algn="bl" rotWithShape="0" blurRad="76200" dist="25400" dir="5400000">
-              <a:srgbClr val="9AA7BD">
-                <a:alpha val="20000"/>
-              </a:srgbClr>
-            </a:outerShdw>
-          </a:effectLst>
         </p:spPr>
       </p:sp>
       <p:sp>
@@ -3465,13 +3430,6 @@
             </a:solidFill>
             <a:prstDash val="solid"/>
           </a:ln>
-          <a:effectLst>
-            <a:outerShdw sx="100000" sy="100000" kx="0" ky="0" algn="bl" rotWithShape="0" blurRad="76200" dist="25400" dir="5400000">
-              <a:srgbClr val="9AA7BD">
-                <a:alpha val="20000"/>
-              </a:srgbClr>
-            </a:outerShdw>
-          </a:effectLst>
         </p:spPr>
       </p:sp>
       <p:sp>
@@ -3898,13 +3856,6 @@
             </a:solidFill>
             <a:prstDash val="solid"/>
           </a:ln>
-          <a:effectLst>
-            <a:outerShdw sx="100000" sy="100000" kx="0" ky="0" algn="bl" rotWithShape="0" blurRad="76200" dist="25400" dir="5400000">
-              <a:srgbClr val="9AA7BD">
-                <a:alpha val="20000"/>
-              </a:srgbClr>
-            </a:outerShdw>
-          </a:effectLst>
         </p:spPr>
       </p:sp>
       <p:sp>
@@ -3971,13 +3922,6 @@
             </a:solidFill>
             <a:prstDash val="solid"/>
           </a:ln>
-          <a:effectLst>
-            <a:outerShdw sx="100000" sy="100000" kx="0" ky="0" algn="bl" rotWithShape="0" blurRad="76200" dist="25400" dir="5400000">
-              <a:srgbClr val="9AA7BD">
-                <a:alpha val="20000"/>
-              </a:srgbClr>
-            </a:outerShdw>
-          </a:effectLst>
         </p:spPr>
       </p:sp>
       <p:sp>
@@ -4044,13 +3988,6 @@
             </a:solidFill>
             <a:prstDash val="solid"/>
           </a:ln>
-          <a:effectLst>
-            <a:outerShdw sx="100000" sy="100000" kx="0" ky="0" algn="bl" rotWithShape="0" blurRad="76200" dist="25400" dir="5400000">
-              <a:srgbClr val="9AA7BD">
-                <a:alpha val="20000"/>
-              </a:srgbClr>
-            </a:outerShdw>
-          </a:effectLst>
         </p:spPr>
       </p:sp>
       <p:sp>
@@ -4117,13 +4054,6 @@
             </a:solidFill>
             <a:prstDash val="solid"/>
           </a:ln>
-          <a:effectLst>
-            <a:outerShdw sx="100000" sy="100000" kx="0" ky="0" algn="bl" rotWithShape="0" blurRad="76200" dist="25400" dir="5400000">
-              <a:srgbClr val="9AA7BD">
-                <a:alpha val="20000"/>
-              </a:srgbClr>
-            </a:outerShdw>
-          </a:effectLst>
         </p:spPr>
       </p:sp>
       <p:sp>
@@ -4423,13 +4353,6 @@
             </a:solidFill>
             <a:prstDash val="solid"/>
           </a:ln>
-          <a:effectLst>
-            <a:outerShdw sx="100000" sy="100000" kx="0" ky="0" algn="bl" rotWithShape="0" blurRad="76200" dist="25400" dir="5400000">
-              <a:srgbClr val="9AA7BD">
-                <a:alpha val="20000"/>
-              </a:srgbClr>
-            </a:outerShdw>
-          </a:effectLst>
         </p:spPr>
       </p:sp>
       <p:sp>
@@ -4562,13 +4485,6 @@
             </a:solidFill>
             <a:prstDash val="solid"/>
           </a:ln>
-          <a:effectLst>
-            <a:outerShdw sx="100000" sy="100000" kx="0" ky="0" algn="bl" rotWithShape="0" blurRad="76200" dist="25400" dir="5400000">
-              <a:srgbClr val="9AA7BD">
-                <a:alpha val="20000"/>
-              </a:srgbClr>
-            </a:outerShdw>
-          </a:effectLst>
         </p:spPr>
       </p:sp>
       <p:sp>
@@ -4701,13 +4617,6 @@
             </a:solidFill>
             <a:prstDash val="solid"/>
           </a:ln>
-          <a:effectLst>
-            <a:outerShdw sx="100000" sy="100000" kx="0" ky="0" algn="bl" rotWithShape="0" blurRad="76200" dist="25400" dir="5400000">
-              <a:srgbClr val="9AA7BD">
-                <a:alpha val="20000"/>
-              </a:srgbClr>
-            </a:outerShdw>
-          </a:effectLst>
         </p:spPr>
       </p:sp>
       <p:sp>
@@ -4840,13 +4749,6 @@
             </a:solidFill>
             <a:prstDash val="solid"/>
           </a:ln>
-          <a:effectLst>
-            <a:outerShdw sx="100000" sy="100000" kx="0" ky="0" algn="bl" rotWithShape="0" blurRad="76200" dist="25400" dir="5400000">
-              <a:srgbClr val="9AA7BD">
-                <a:alpha val="20000"/>
-              </a:srgbClr>
-            </a:outerShdw>
-          </a:effectLst>
         </p:spPr>
       </p:sp>
       <p:sp>
@@ -4979,13 +4881,6 @@
             </a:solidFill>
             <a:prstDash val="solid"/>
           </a:ln>
-          <a:effectLst>
-            <a:outerShdw sx="100000" sy="100000" kx="0" ky="0" algn="bl" rotWithShape="0" blurRad="76200" dist="25400" dir="5400000">
-              <a:srgbClr val="9AA7BD">
-                <a:alpha val="20000"/>
-              </a:srgbClr>
-            </a:outerShdw>
-          </a:effectLst>
         </p:spPr>
       </p:sp>
       <p:sp>
@@ -6413,13 +6308,6 @@
             </a:solidFill>
             <a:prstDash val="solid"/>
           </a:ln>
-          <a:effectLst>
-            <a:outerShdw sx="100000" sy="100000" kx="0" ky="0" algn="bl" rotWithShape="0" blurRad="76200" dist="25400" dir="5400000">
-              <a:srgbClr val="9AA7BD">
-                <a:alpha val="20000"/>
-              </a:srgbClr>
-            </a:outerShdw>
-          </a:effectLst>
         </p:spPr>
       </p:sp>
       <p:sp>
@@ -6722,13 +6610,6 @@
             </a:solidFill>
             <a:prstDash val="solid"/>
           </a:ln>
-          <a:effectLst>
-            <a:outerShdw sx="100000" sy="100000" kx="0" ky="0" algn="bl" rotWithShape="0" blurRad="76200" dist="25400" dir="5400000">
-              <a:srgbClr val="9AA7BD">
-                <a:alpha val="20000"/>
-              </a:srgbClr>
-            </a:outerShdw>
-          </a:effectLst>
         </p:spPr>
       </p:sp>
       <p:sp>
@@ -6876,13 +6757,6 @@
             </a:solidFill>
             <a:prstDash val="solid"/>
           </a:ln>
-          <a:effectLst>
-            <a:outerShdw sx="100000" sy="100000" kx="0" ky="0" algn="bl" rotWithShape="0" blurRad="76200" dist="25400" dir="5400000">
-              <a:srgbClr val="9AA7BD">
-                <a:alpha val="20000"/>
-              </a:srgbClr>
-            </a:outerShdw>
-          </a:effectLst>
         </p:spPr>
       </p:sp>
       <p:sp>
@@ -7030,13 +6904,6 @@
             </a:solidFill>
             <a:prstDash val="solid"/>
           </a:ln>
-          <a:effectLst>
-            <a:outerShdw sx="100000" sy="100000" kx="0" ky="0" algn="bl" rotWithShape="0" blurRad="76200" dist="25400" dir="5400000">
-              <a:srgbClr val="9AA7BD">
-                <a:alpha val="20000"/>
-              </a:srgbClr>
-            </a:outerShdw>
-          </a:effectLst>
         </p:spPr>
       </p:sp>
       <p:sp>
@@ -7184,13 +7051,6 @@
             </a:solidFill>
             <a:prstDash val="solid"/>
           </a:ln>
-          <a:effectLst>
-            <a:outerShdw sx="100000" sy="100000" kx="0" ky="0" algn="bl" rotWithShape="0" blurRad="76200" dist="25400" dir="5400000">
-              <a:srgbClr val="9AA7BD">
-                <a:alpha val="20000"/>
-              </a:srgbClr>
-            </a:outerShdw>
-          </a:effectLst>
         </p:spPr>
       </p:sp>
       <p:sp>
@@ -8231,13 +8091,6 @@
             </a:solidFill>
             <a:prstDash val="solid"/>
           </a:ln>
-          <a:effectLst>
-            <a:outerShdw sx="100000" sy="100000" kx="0" ky="0" algn="bl" rotWithShape="0" blurRad="76200" dist="25400" dir="5400000">
-              <a:srgbClr val="9AA7BD">
-                <a:alpha val="20000"/>
-              </a:srgbClr>
-            </a:outerShdw>
-          </a:effectLst>
         </p:spPr>
       </p:sp>
       <p:sp>
@@ -8518,13 +8371,6 @@
             </a:solidFill>
             <a:prstDash val="solid"/>
           </a:ln>
-          <a:effectLst>
-            <a:outerShdw sx="100000" sy="100000" kx="0" ky="0" algn="bl" rotWithShape="0" blurRad="76200" dist="25400" dir="5400000">
-              <a:srgbClr val="9AA7BD">
-                <a:alpha val="20000"/>
-              </a:srgbClr>
-            </a:outerShdw>
-          </a:effectLst>
         </p:spPr>
       </p:sp>
       <p:sp>
@@ -8633,13 +8479,6 @@
             </a:solidFill>
             <a:prstDash val="solid"/>
           </a:ln>
-          <a:effectLst>
-            <a:outerShdw sx="100000" sy="100000" kx="0" ky="0" algn="bl" rotWithShape="0" blurRad="76200" dist="25400" dir="5400000">
-              <a:srgbClr val="9AA7BD">
-                <a:alpha val="20000"/>
-              </a:srgbClr>
-            </a:outerShdw>
-          </a:effectLst>
         </p:spPr>
       </p:sp>
       <p:sp>
@@ -8748,13 +8587,6 @@
             </a:solidFill>
             <a:prstDash val="solid"/>
           </a:ln>
-          <a:effectLst>
-            <a:outerShdw sx="100000" sy="100000" kx="0" ky="0" algn="bl" rotWithShape="0" blurRad="76200" dist="25400" dir="5400000">
-              <a:srgbClr val="9AA7BD">
-                <a:alpha val="20000"/>
-              </a:srgbClr>
-            </a:outerShdw>
-          </a:effectLst>
         </p:spPr>
       </p:sp>
       <p:sp>

</xml_diff>